<commit_message>
Use a footer-sized logo so decks drop from ~780KB to ~265KB
Co-Authored-By: Claude Opus 5.5 <noreply@anthropic.com>
Claude-Session: https://claude.ai/code/session_013NTtu8AGu8tQwxyxRyJapw
</commit_message>
<xml_diff>
--- a/weeks/2026-09-28/decks/Sabio_Activision_Shooter_Audiences_9.30.26.pptx
+++ b/weeks/2026-09-28/decks/Sabio_Activision_Shooter_Audiences_9.30.26.pptx
@@ -3065,7 +3065,7 @@
       </p:sp>
       <p:pic>
         <p:nvPicPr>
-          <p:cNvPr id="7" name="Image 0" descr="/home/user/Sabio-Deck-Builders-/assets/sabio-logo-white.png">    </p:cNvPr>
+          <p:cNvPr id="7" name="Image 0" descr="/home/user/Sabio-Deck-Builders-/assets/sabio-logo-white-sm.png">    </p:cNvPr>
           <p:cNvPicPr>
             <a:picLocks noChangeAspect="1"/>
           </p:cNvPicPr>
@@ -4218,7 +4218,7 @@
       </p:sp>
       <p:pic>
         <p:nvPicPr>
-          <p:cNvPr id="7" name="Image 0" descr="/home/user/Sabio-Deck-Builders-/assets/sabio-logo-white.png">    </p:cNvPr>
+          <p:cNvPr id="7" name="Image 0" descr="/home/user/Sabio-Deck-Builders-/assets/sabio-logo-white-sm.png">    </p:cNvPr>
           <p:cNvPicPr>
             <a:picLocks noChangeAspect="1"/>
           </p:cNvPicPr>
@@ -5030,7 +5030,7 @@
       </p:sp>
       <p:pic>
         <p:nvPicPr>
-          <p:cNvPr id="7" name="Image 0" descr="/home/user/Sabio-Deck-Builders-/assets/sabio-logo-white.png">    </p:cNvPr>
+          <p:cNvPr id="7" name="Image 0" descr="/home/user/Sabio-Deck-Builders-/assets/sabio-logo-white-sm.png">    </p:cNvPr>
           <p:cNvPicPr>
             <a:picLocks noChangeAspect="1"/>
           </p:cNvPicPr>
@@ -5860,7 +5860,7 @@
       </p:sp>
       <p:pic>
         <p:nvPicPr>
-          <p:cNvPr id="6" name="Image 0" descr="/home/user/Sabio-Deck-Builders-/assets/sabio-logo-white.png">    </p:cNvPr>
+          <p:cNvPr id="6" name="Image 0" descr="/home/user/Sabio-Deck-Builders-/assets/sabio-logo-white-sm.png">    </p:cNvPr>
           <p:cNvPicPr>
             <a:picLocks noChangeAspect="1"/>
           </p:cNvPicPr>
@@ -7186,7 +7186,7 @@
       </p:sp>
       <p:pic>
         <p:nvPicPr>
-          <p:cNvPr id="6" name="Image 0" descr="/home/user/Sabio-Deck-Builders-/assets/sabio-logo-white.png">    </p:cNvPr>
+          <p:cNvPr id="6" name="Image 0" descr="/home/user/Sabio-Deck-Builders-/assets/sabio-logo-white-sm.png">    </p:cNvPr>
           <p:cNvPicPr>
             <a:picLocks noChangeAspect="1"/>
           </p:cNvPicPr>
@@ -7523,7 +7523,7 @@
       </p:sp>
       <p:pic>
         <p:nvPicPr>
-          <p:cNvPr id="5" name="Image 0" descr="/home/user/Sabio-Deck-Builders-/assets/sabio-logo-white.png">    </p:cNvPr>
+          <p:cNvPr id="5" name="Image 0" descr="/home/user/Sabio-Deck-Builders-/assets/sabio-logo-white-sm.png">    </p:cNvPr>
           <p:cNvPicPr>
             <a:picLocks noChangeAspect="1"/>
           </p:cNvPicPr>
@@ -8357,7 +8357,7 @@
       </p:sp>
       <p:pic>
         <p:nvPicPr>
-          <p:cNvPr id="6" name="Image 0" descr="/home/user/Sabio-Deck-Builders-/assets/sabio-logo-white.png">    </p:cNvPr>
+          <p:cNvPr id="6" name="Image 0" descr="/home/user/Sabio-Deck-Builders-/assets/sabio-logo-white-sm.png">    </p:cNvPr>
           <p:cNvPicPr>
             <a:picLocks noChangeAspect="1"/>
           </p:cNvPicPr>
@@ -9549,7 +9549,7 @@
       </p:sp>
       <p:pic>
         <p:nvPicPr>
-          <p:cNvPr id="6" name="Image 0" descr="/home/user/Sabio-Deck-Builders-/assets/sabio-logo-white.png">    </p:cNvPr>
+          <p:cNvPr id="6" name="Image 0" descr="/home/user/Sabio-Deck-Builders-/assets/sabio-logo-white-sm.png">    </p:cNvPr>
           <p:cNvPicPr>
             <a:picLocks noChangeAspect="1"/>
           </p:cNvPicPr>
@@ -10176,7 +10176,7 @@
       </p:sp>
       <p:pic>
         <p:nvPicPr>
-          <p:cNvPr id="6" name="Image 0" descr="/home/user/Sabio-Deck-Builders-/assets/sabio-logo-white.png">    </p:cNvPr>
+          <p:cNvPr id="6" name="Image 0" descr="/home/user/Sabio-Deck-Builders-/assets/sabio-logo-white-sm.png">    </p:cNvPr>
           <p:cNvPicPr>
             <a:picLocks noChangeAspect="1"/>
           </p:cNvPicPr>
@@ -11254,7 +11254,7 @@
       </p:sp>
       <p:pic>
         <p:nvPicPr>
-          <p:cNvPr id="7" name="Image 0" descr="/home/user/Sabio-Deck-Builders-/assets/sabio-logo-white.png">    </p:cNvPr>
+          <p:cNvPr id="7" name="Image 0" descr="/home/user/Sabio-Deck-Builders-/assets/sabio-logo-white-sm.png">    </p:cNvPr>
           <p:cNvPicPr>
             <a:picLocks noChangeAspect="1"/>
           </p:cNvPicPr>
@@ -12591,7 +12591,7 @@
       </p:sp>
       <p:pic>
         <p:nvPicPr>
-          <p:cNvPr id="7" name="Image 0" descr="/home/user/Sabio-Deck-Builders-/assets/sabio-logo-white.png">    </p:cNvPr>
+          <p:cNvPr id="7" name="Image 0" descr="/home/user/Sabio-Deck-Builders-/assets/sabio-logo-white-sm.png">    </p:cNvPr>
           <p:cNvPicPr>
             <a:picLocks noChangeAspect="1"/>
           </p:cNvPicPr>
@@ -13023,7 +13023,7 @@
       </p:sp>
       <p:pic>
         <p:nvPicPr>
-          <p:cNvPr id="7" name="Image 0" descr="/home/user/Sabio-Deck-Builders-/assets/sabio-logo-white.png">    </p:cNvPr>
+          <p:cNvPr id="7" name="Image 0" descr="/home/user/Sabio-Deck-Builders-/assets/sabio-logo-white-sm.png">    </p:cNvPr>
           <p:cNvPicPr>
             <a:picLocks noChangeAspect="1"/>
           </p:cNvPicPr>
@@ -13838,7 +13838,7 @@
       </p:sp>
       <p:pic>
         <p:nvPicPr>
-          <p:cNvPr id="6" name="Image 0" descr="/home/user/Sabio-Deck-Builders-/assets/sabio-logo-white.png">    </p:cNvPr>
+          <p:cNvPr id="6" name="Image 0" descr="/home/user/Sabio-Deck-Builders-/assets/sabio-logo-white-sm.png">    </p:cNvPr>
           <p:cNvPicPr>
             <a:picLocks noChangeAspect="1"/>
           </p:cNvPicPr>

</xml_diff>